<commit_message>
chore(slides): rebuild weeks 5-6 from re-run results
</commit_message>
<xml_diff>
--- a/slides/week05_progress.pptx
+++ b/slides/week05_progress.pptx
@@ -7299,7 +7299,7 @@
                           </a:solidFill>
                           <a:latin typeface="Calibri"/>
                         </a:rPr>
-                        <a:t>0.983 ± 0.002</a:t>
+                        <a:t>0.981 ± 0.001</a:t>
                       </a:r>
                     </a:p>
                   </a:txBody>
@@ -7321,7 +7321,7 @@
                           </a:solidFill>
                           <a:latin typeface="Calibri"/>
                         </a:rPr>
-                        <a:t>0.838 ± 0.015</a:t>
+                        <a:t>0.820 ± 0.008</a:t>
                       </a:r>
                     </a:p>
                   </a:txBody>
@@ -7343,7 +7343,7 @@
                           </a:solidFill>
                           <a:latin typeface="Calibri"/>
                         </a:rPr>
-                        <a:t>0.859 ± 0.012</a:t>
+                        <a:t>0.840 ± 0.008</a:t>
                       </a:r>
                     </a:p>
                   </a:txBody>
@@ -7433,7 +7433,7 @@
                           </a:solidFill>
                           <a:latin typeface="Calibri"/>
                         </a:rPr>
-                        <a:t>0.966 ± 0.001</a:t>
+                        <a:t>0.963 ± 0.001</a:t>
                       </a:r>
                     </a:p>
                   </a:txBody>
@@ -7455,7 +7455,7 @@
                           </a:solidFill>
                           <a:latin typeface="Calibri"/>
                         </a:rPr>
-                        <a:t>0.759 ± 0.007</a:t>
+                        <a:t>0.749 ± 0.001</a:t>
                       </a:r>
                     </a:p>
                   </a:txBody>
@@ -7477,7 +7477,7 @@
                           </a:solidFill>
                           <a:latin typeface="Calibri"/>
                         </a:rPr>
-                        <a:t>0.795 ± 0.008</a:t>
+                        <a:t>0.779 ± 0.001</a:t>
                       </a:r>
                     </a:p>
                   </a:txBody>
@@ -7567,7 +7567,7 @@
                           </a:solidFill>
                           <a:latin typeface="Calibri"/>
                         </a:rPr>
-                        <a:t>0.940 ± 0.007</a:t>
+                        <a:t>0.939 ± 0.002</a:t>
                       </a:r>
                     </a:p>
                   </a:txBody>
@@ -7589,7 +7589,7 @@
                           </a:solidFill>
                           <a:latin typeface="Calibri"/>
                         </a:rPr>
-                        <a:t>0.838 ± 0.008</a:t>
+                        <a:t>0.868 ± 0.003</a:t>
                       </a:r>
                     </a:p>
                   </a:txBody>
@@ -7611,7 +7611,7 @@
                           </a:solidFill>
                           <a:latin typeface="Calibri"/>
                         </a:rPr>
-                        <a:t>0.859 ± 0.007</a:t>
+                        <a:t>0.881 ± 0.000</a:t>
                       </a:r>
                     </a:p>
                   </a:txBody>
@@ -7701,7 +7701,7 @@
                           </a:solidFill>
                           <a:latin typeface="Calibri"/>
                         </a:rPr>
-                        <a:t>0.918 ± 0.006</a:t>
+                        <a:t>0.928 ± 0.007</a:t>
                       </a:r>
                     </a:p>
                   </a:txBody>
@@ -7723,7 +7723,7 @@
                           </a:solidFill>
                           <a:latin typeface="Calibri"/>
                         </a:rPr>
-                        <a:t>0.785 ± 0.002</a:t>
+                        <a:t>0.807 ± 0.017</a:t>
                       </a:r>
                     </a:p>
                   </a:txBody>
@@ -7745,7 +7745,7 @@
                           </a:solidFill>
                           <a:latin typeface="Calibri"/>
                         </a:rPr>
-                        <a:t>0.817 ± 0.003</a:t>
+                        <a:t>0.832 ± 0.011</a:t>
                       </a:r>
                     </a:p>
                   </a:txBody>
@@ -7835,7 +7835,7 @@
                           </a:solidFill>
                           <a:latin typeface="Calibri"/>
                         </a:rPr>
-                        <a:t>0.888 ± 0.001</a:t>
+                        <a:t>0.874 ± 0.003</a:t>
                       </a:r>
                     </a:p>
                   </a:txBody>
@@ -7857,7 +7857,7 @@
                           </a:solidFill>
                           <a:latin typeface="Calibri"/>
                         </a:rPr>
-                        <a:t>0.363 ± 0.005</a:t>
+                        <a:t>0.372 ± 0.003</a:t>
                       </a:r>
                     </a:p>
                   </a:txBody>
@@ -7879,7 +7879,7 @@
                           </a:solidFill>
                           <a:latin typeface="Calibri"/>
                         </a:rPr>
-                        <a:t>0.723 ± 0.001</a:t>
+                        <a:t>0.546 ± 0.005</a:t>
                       </a:r>
                     </a:p>
                   </a:txBody>
@@ -7969,7 +7969,7 @@
                           </a:solidFill>
                           <a:latin typeface="Calibri"/>
                         </a:rPr>
-                        <a:t>0.837 ± 0.007</a:t>
+                        <a:t>0.820 ± 0.019</a:t>
                       </a:r>
                     </a:p>
                   </a:txBody>
@@ -7991,7 +7991,7 @@
                           </a:solidFill>
                           <a:latin typeface="Calibri"/>
                         </a:rPr>
-                        <a:t>0.274 ± 0.023</a:t>
+                        <a:t>0.295 ± 0.019</a:t>
                       </a:r>
                     </a:p>
                   </a:txBody>
@@ -8013,7 +8013,7 @@
                           </a:solidFill>
                           <a:latin typeface="Calibri"/>
                         </a:rPr>
-                        <a:t>0.688 ± 0.002</a:t>
+                        <a:t>0.529 ± 0.028</a:t>
                       </a:r>
                     </a:p>
                   </a:txBody>
@@ -8599,7 +8599,7 @@
                           </a:solidFill>
                           <a:latin typeface="Calibri"/>
                         </a:rPr>
-                        <a:t>0.783 ± 0.003</a:t>
+                        <a:t>0.794 ± 0.009</a:t>
                       </a:r>
                     </a:p>
                   </a:txBody>
@@ -8621,7 +8621,7 @@
                           </a:solidFill>
                           <a:latin typeface="Calibri"/>
                         </a:rPr>
-                        <a:t>0.428 ± 0.003</a:t>
+                        <a:t>0.437 ± 0.008</a:t>
                       </a:r>
                     </a:p>
                   </a:txBody>
@@ -8689,7 +8689,7 @@
                           </a:solidFill>
                           <a:latin typeface="Calibri"/>
                         </a:rPr>
-                        <a:t>0.727 ± 0.017</a:t>
+                        <a:t>0.745 ± 0.010</a:t>
                       </a:r>
                     </a:p>
                   </a:txBody>
@@ -8711,7 +8711,7 @@
                           </a:solidFill>
                           <a:latin typeface="Calibri"/>
                         </a:rPr>
-                        <a:t>0.324 ± 0.022</a:t>
+                        <a:t>0.329 ± 0.036</a:t>
                       </a:r>
                     </a:p>
                   </a:txBody>
@@ -8779,7 +8779,7 @@
                           </a:solidFill>
                           <a:latin typeface="Calibri"/>
                         </a:rPr>
-                        <a:t>0.778 ± 0.006</a:t>
+                        <a:t>0.792 ± 0.017</a:t>
                       </a:r>
                     </a:p>
                   </a:txBody>
@@ -8801,7 +8801,7 @@
                           </a:solidFill>
                           <a:latin typeface="Calibri"/>
                         </a:rPr>
-                        <a:t>0.425 ± 0.021</a:t>
+                        <a:t>0.455 ± 0.021</a:t>
                       </a:r>
                     </a:p>
                   </a:txBody>
@@ -8869,7 +8869,7 @@
                           </a:solidFill>
                           <a:latin typeface="Calibri"/>
                         </a:rPr>
-                        <a:t>0.763 ± 0.018</a:t>
+                        <a:t>0.756 ± 0.003</a:t>
                       </a:r>
                     </a:p>
                   </a:txBody>
@@ -8891,7 +8891,7 @@
                           </a:solidFill>
                           <a:latin typeface="Calibri"/>
                         </a:rPr>
-                        <a:t>0.366 ± 0.035</a:t>
+                        <a:t>0.346 ± 0.016</a:t>
                       </a:r>
                     </a:p>
                   </a:txBody>
@@ -8959,7 +8959,7 @@
                           </a:solidFill>
                           <a:latin typeface="Calibri"/>
                         </a:rPr>
-                        <a:t>0.783 ± 0.003</a:t>
+                        <a:t>0.800 ± 0.010</a:t>
                       </a:r>
                     </a:p>
                   </a:txBody>
@@ -8981,7 +8981,7 @@
                           </a:solidFill>
                           <a:latin typeface="Calibri"/>
                         </a:rPr>
-                        <a:t>0.436 ± 0.027</a:t>
+                        <a:t>0.440 ± 0.014</a:t>
                       </a:r>
                     </a:p>
                   </a:txBody>
@@ -9271,7 +9271,7 @@
                           </a:solidFill>
                           <a:latin typeface="Calibri"/>
                         </a:rPr>
-                        <a:t>0.047 ± 0.000</a:t>
+                        <a:t>0.081 ± 0.034</a:t>
                       </a:r>
                     </a:p>
                   </a:txBody>
@@ -9339,7 +9339,7 @@
                           </a:solidFill>
                           <a:latin typeface="Calibri"/>
                         </a:rPr>
-                        <a:t>0.152 ± 0.019</a:t>
+                        <a:t>0.159 ± 0.016</a:t>
                       </a:r>
                     </a:p>
                   </a:txBody>
@@ -9407,7 +9407,7 @@
                           </a:solidFill>
                           <a:latin typeface="Calibri"/>
                         </a:rPr>
-                        <a:t>0.102 ± 0.018</a:t>
+                        <a:t>0.111 ± 0.009</a:t>
                       </a:r>
                     </a:p>
                   </a:txBody>
@@ -9525,7 +9525,7 @@
                           </a:solidFill>
                           <a:latin typeface="Calibri"/>
                         </a:rPr>
-                        <a:t>auroc 0.962 ± 0.001</a:t>
+                        <a:t>auroc 0.958 ± 0.005</a:t>
                       </a:r>
                     </a:p>
                   </a:txBody>
@@ -9571,7 +9571,7 @@
                           </a:solidFill>
                           <a:latin typeface="Calibri"/>
                         </a:rPr>
-                        <a:t>auroc 0.729 ± 0.006</a:t>
+                        <a:t>auroc 0.752 ± 0.019</a:t>
                       </a:r>
                     </a:p>
                   </a:txBody>
@@ -9617,7 +9617,7 @@
                           </a:solidFill>
                           <a:latin typeface="Calibri"/>
                         </a:rPr>
-                        <a:t>macro_f1 0.137 ± 0.007</a:t>
+                        <a:t>macro_f1 0.118 ± 0.026</a:t>
                       </a:r>
                     </a:p>
                   </a:txBody>

</xml_diff>